<commit_message>
Vercel deployment live: screen-wise.vercel.app
- Added proxy fallback in /api/screen for Vercel (internal-api.z.ai unreachable from Vercel)
- Vercel detects VERCEL env var → proxies to sandbox preview URL → ZAI API
- All 6 env vars set on Vercel: ZAI_API_KEY, ZAI_BASE_URL, ZAI_CHAT_ID, ZAI_USER_ID, ZAI_TOKEN, PROXY_FALLBACK_URL
- Updated slide 5 with live URLs: screen-wise.vercel.app + github.com/Hemantth123/screenwise-AI
- Regenerated PPTX with live links
- Verified end-to-end: home page loads, API returns valid AI evaluations in ~4s

Live deployment: https://screen-wise.vercel.app
</commit_message>
<xml_diff>
--- a/download/ScreenWise-Pitch-Deck.pptx
+++ b/download/ScreenWise-Pitch-Deck.pptx
@@ -12088,7 +12088,7 @@
       </p:sp>
       <p:pic>
         <p:nvPicPr>
-          <p:cNvPr id="8" name="Image 0" descr="/tmp/h2p-fit-1781927718168-n2gab8.png">    </p:cNvPr>
+          <p:cNvPr id="8" name="Image 0" descr="/tmp/h2p-fit-1782017089947-5emff5.png">    </p:cNvPr>
           <p:cNvPicPr>
             <a:picLocks noChangeAspect="1"/>
           </p:cNvPicPr>
@@ -12208,7 +12208,7 @@
       </p:sp>
       <p:pic>
         <p:nvPicPr>
-          <p:cNvPr id="11" name="Image 1" descr="/tmp/h2p-fit-1781927718171-kjsf8a.png">    </p:cNvPr>
+          <p:cNvPr id="11" name="Image 1" descr="/tmp/h2p-fit-1782017089946-bgs6go.png">    </p:cNvPr>
           <p:cNvPicPr>
             <a:picLocks noChangeAspect="1"/>
           </p:cNvPicPr>
@@ -12328,7 +12328,7 @@
       </p:sp>
       <p:pic>
         <p:nvPicPr>
-          <p:cNvPr id="14" name="Image 2" descr="/tmp/h2p-fit-1781927718170-hm73ks.png">    </p:cNvPr>
+          <p:cNvPr id="14" name="Image 2" descr="/tmp/h2p-fit-1782017089947-egrfmj.png">    </p:cNvPr>
           <p:cNvPicPr>
             <a:picLocks noChangeAspect="1"/>
           </p:cNvPicPr>
@@ -12714,7 +12714,7 @@
                 <a:ea typeface="Courier New" pitchFamily="34" charset="-122"/>
                 <a:cs typeface="Courier New" pitchFamily="34" charset="-120"/>
               </a:rPr>
-              <a:t>Preview Panel → / route (this app)</a:t>
+              <a:t>screen-wise.vercel.app</a:t>
             </a:r>
             <a:endParaRPr lang="en-US" sz="800" dirty="0"/>
           </a:p>
@@ -12856,11 +12856,11 @@
                 <a:solidFill>
                   <a:srgbClr val="047857"/>
                 </a:solidFill>
-                <a:latin typeface="Courier New" pitchFamily="34" charset="0"/>
-                <a:ea typeface="Courier New" pitchFamily="34" charset="-122"/>
-                <a:cs typeface="Courier New" pitchFamily="34" charset="-120"/>
-              </a:rPr>
-              <a:t>github.com/screenwise-ai/screenwise</a:t>
+                <a:latin typeface="Liberation Sans Narrow" pitchFamily="34" charset="0"/>
+                <a:ea typeface="Liberation Sans Narrow" pitchFamily="34" charset="-122"/>
+                <a:cs typeface="Liberation Sans Narrow" pitchFamily="34" charset="-120"/>
+              </a:rPr>
+              <a:t>github.com/Hemantth123/screenwise-AI</a:t>
             </a:r>
             <a:endParaRPr lang="en-US" sz="800" dirty="0"/>
           </a:p>

</xml_diff>